<commit_message>
Adding Final Report  and commiting final changes to the streamlit app
</commit_message>
<xml_diff>
--- a/Crypto Fraud Presentation.pptx
+++ b/Crypto Fraud Presentation.pptx
@@ -124,7 +124,7 @@
   <pc:docChgLst>
     <pc:chgData name="Manolis Tsiftsis" userId="04aaece2082b40e7" providerId="LiveId" clId="{48442419-AC4D-4915-A70C-70FF2F296BDB}"/>
     <pc:docChg chg="modSld">
-      <pc:chgData name="Manolis Tsiftsis" userId="04aaece2082b40e7" providerId="LiveId" clId="{48442419-AC4D-4915-A70C-70FF2F296BDB}" dt="2026-10-18T20:48:25.552" v="13" actId="20577"/>
+      <pc:chgData name="Manolis Tsiftsis" userId="04aaece2082b40e7" providerId="LiveId" clId="{48442419-AC4D-4915-A70C-70FF2F296BDB}" dt="2026-10-20T16:04:37.524" v="73" actId="20577"/>
       <pc:docMkLst>
         <pc:docMk/>
       </pc:docMkLst>
@@ -135,12 +135,20 @@
           <pc:sldMk cId="0" sldId="256"/>
         </pc:sldMkLst>
       </pc:sldChg>
-      <pc:sldChg chg="modNotesTx">
-        <pc:chgData name="Manolis Tsiftsis" userId="04aaece2082b40e7" providerId="LiveId" clId="{48442419-AC4D-4915-A70C-70FF2F296BDB}" dt="2026-10-18T20:47:54.110" v="5" actId="20577"/>
+      <pc:sldChg chg="modSp mod modNotesTx">
+        <pc:chgData name="Manolis Tsiftsis" userId="04aaece2082b40e7" providerId="LiveId" clId="{48442419-AC4D-4915-A70C-70FF2F296BDB}" dt="2026-10-20T16:04:37.524" v="73" actId="20577"/>
         <pc:sldMkLst>
           <pc:docMk/>
           <pc:sldMk cId="0" sldId="257"/>
         </pc:sldMkLst>
+        <pc:spChg chg="mod">
+          <ac:chgData name="Manolis Tsiftsis" userId="04aaece2082b40e7" providerId="LiveId" clId="{48442419-AC4D-4915-A70C-70FF2F296BDB}" dt="2026-10-20T16:04:37.524" v="73" actId="20577"/>
+          <ac:spMkLst>
+            <pc:docMk/>
+            <pc:sldMk cId="0" sldId="257"/>
+            <ac:spMk id="4" creationId="{00000000-0000-0000-0000-000000000000}"/>
+          </ac:spMkLst>
+        </pc:spChg>
       </pc:sldChg>
       <pc:sldChg chg="modNotesTx">
         <pc:chgData name="Manolis Tsiftsis" userId="04aaece2082b40e7" providerId="LiveId" clId="{48442419-AC4D-4915-A70C-70FF2F296BDB}" dt="2026-10-18T20:48:02.434" v="8" actId="20577"/>
@@ -1860,7 +1868,18 @@
                 <a:ea typeface="Inter" pitchFamily="34" charset="-122"/>
                 <a:cs typeface="Inter" pitchFamily="34" charset="-120"/>
               </a:rPr>
-              <a:t>Vadim</a:t>
+              <a:t>Vadim()  #he is </a:t>
+            </a:r>
+            <a:r>
+              <a:rPr lang="en-US" sz="2800">
+                <a:solidFill>
+                  <a:srgbClr val="1D1D1F"/>
+                </a:solidFill>
+                <a:latin typeface="Inter" pitchFamily="34" charset="0"/>
+                <a:ea typeface="Inter" pitchFamily="34" charset="-122"/>
+                <a:cs typeface="Inter" pitchFamily="34" charset="-120"/>
+              </a:rPr>
+              <a:t>a function </a:t>
             </a:r>
             <a:endParaRPr lang="en-US" sz="2800" dirty="0"/>
           </a:p>

</xml_diff>